<commit_message>
Streamline defense presentation to 8 slides, remove redundant slides 3/5/6/7/8, and detail Prototyping SDLC phases
</commit_message>
<xml_diff>
--- a/Professional_Project_Defense_Presentation_AuraQA.pptx
+++ b/Professional_Project_Defense_Presentation_AuraQA.pptx
@@ -13,10 +13,6 @@
     <p:sldId id="261" r:id="rId12"/>
     <p:sldId id="262" r:id="rId13"/>
     <p:sldId id="263" r:id="rId14"/>
-    <p:sldId id="264" r:id="rId15"/>
-    <p:sldId id="265" r:id="rId16"/>
-    <p:sldId id="266" r:id="rId17"/>
-    <p:sldId id="267" r:id="rId18"/>
   </p:sldIdLst>
   <p:sldSz cx="12191695" cy="6858000" type="screen4x3"/>
   <p:notesSz cx="6858000" cy="9144000"/>
@@ -3122,7 +3118,7 @@
           <a:lstStyle/>
           <a:p>
             <a:pPr>
-              <a:defRPr sz="2000" b="1">
+              <a:defRPr sz="1900" b="1">
                 <a:solidFill>
                   <a:srgbClr val="1F4E78"/>
                 </a:solidFill>
@@ -3280,546 +3276,6 @@
                 </a:solidFill>
               </a:rPr>
               <a:t>July, 2026</a:t>
-            </a:r>
-          </a:p>
-        </p:txBody>
-      </p:sp>
-    </p:spTree>
-  </p:cSld>
-  <p:clrMapOvr>
-    <a:masterClrMapping/>
-  </p:clrMapOvr>
-</p:sld>
-</file>
-
-<file path=ppt/slides/slide10.xml><?xml version="1.0" encoding="utf-8"?>
-<p:sld xmlns:a="http://schemas.openxmlformats.org/drawingml/2006/main" xmlns:p="http://schemas.openxmlformats.org/presentationml/2006/main" xmlns:r="http://schemas.openxmlformats.org/officeDocument/2006/relationships">
-  <p:cSld>
-    <p:spTree>
-      <p:nvGrpSpPr>
-        <p:cNvPr id="1" name=""/>
-        <p:cNvGrpSpPr/>
-        <p:nvPr/>
-      </p:nvGrpSpPr>
-      <p:grpSpPr/>
-      <p:sp>
-        <p:nvSpPr>
-          <p:cNvPr id="2" name="TextBox 1"/>
-          <p:cNvSpPr txBox="1"/>
-          <p:nvPr/>
-        </p:nvSpPr>
-        <p:spPr>
-          <a:xfrm>
-            <a:off x="731520" y="457200"/>
-            <a:ext cx="10698480" cy="1097280"/>
-          </a:xfrm>
-          <a:prstGeom prst="rect">
-            <a:avLst/>
-          </a:prstGeom>
-          <a:noFill/>
-        </p:spPr>
-        <p:txBody>
-          <a:bodyPr wrap="square">
-            <a:spAutoFit/>
-          </a:bodyPr>
-          <a:lstStyle/>
-          <a:p>
-            <a:pPr>
-              <a:defRPr sz="2200" b="1">
-                <a:solidFill>
-                  <a:srgbClr val="1F4E78"/>
-                </a:solidFill>
-              </a:defRPr>
-            </a:pPr>
-            <a:r>
-              <a:t>SLIDE 10: CONCLUSION AND CONTRIBUTIONS</a:t>
-            </a:r>
-          </a:p>
-          <a:p>
-            <a:pPr>
-              <a:defRPr sz="1300" i="1">
-                <a:solidFill>
-                  <a:srgbClr val="595959"/>
-                </a:solidFill>
-              </a:defRPr>
-            </a:pPr>
-            <a:r>
-              <a:t>Summary of Accomplishments and Significance</a:t>
-            </a:r>
-          </a:p>
-        </p:txBody>
-      </p:sp>
-      <p:sp>
-        <p:nvSpPr>
-          <p:cNvPr id="3" name="TextBox 2"/>
-          <p:cNvSpPr txBox="1"/>
-          <p:nvPr/>
-        </p:nvSpPr>
-        <p:spPr>
-          <a:xfrm>
-            <a:off x="731520" y="1645920"/>
-            <a:ext cx="10698480" cy="4572000"/>
-          </a:xfrm>
-          <a:prstGeom prst="rect">
-            <a:avLst/>
-          </a:prstGeom>
-          <a:noFill/>
-        </p:spPr>
-        <p:txBody>
-          <a:bodyPr wrap="square">
-            <a:spAutoFit/>
-          </a:bodyPr>
-          <a:lstStyle/>
-          <a:p>
-            <a:pPr>
-              <a:spcAft>
-                <a:spcPts val="1000"/>
-              </a:spcAft>
-            </a:pPr>
-            <a:r>
-              <a:rPr b="1" sz="1500">
-                <a:solidFill>
-                  <a:srgbClr val="1F4E78"/>
-                </a:solidFill>
-              </a:rPr>
-              <a:t>Summary: </a:t>
-            </a:r>
-            <a:r>
-              <a:rPr sz="1500">
-                <a:solidFill>
-                  <a:srgbClr val="333333"/>
-                </a:solidFill>
-              </a:rPr>
-              <a:t>AuraQA successfully proves that high-performance, secure AI document intelligence is achievable locally on CPU hardware.</a:t>
-            </a:r>
-          </a:p>
-          <a:p>
-            <a:pPr>
-              <a:spcAft>
-                <a:spcPts val="1000"/>
-              </a:spcAft>
-            </a:pPr>
-            <a:r>
-              <a:rPr b="1" sz="1500">
-                <a:solidFill>
-                  <a:srgbClr val="1F4E78"/>
-                </a:solidFill>
-              </a:rPr>
-              <a:t>Data Sovereignty: </a:t>
-            </a:r>
-            <a:r>
-              <a:rPr sz="1500">
-                <a:solidFill>
-                  <a:srgbClr val="333333"/>
-                </a:solidFill>
-              </a:rPr>
-              <a:t>Eliminates all third-party cloud data transmission, ensuring 100% user data privacy.</a:t>
-            </a:r>
-          </a:p>
-          <a:p>
-            <a:pPr>
-              <a:spcAft>
-                <a:spcPts val="1000"/>
-              </a:spcAft>
-            </a:pPr>
-            <a:r>
-              <a:rPr b="1" sz="1500">
-                <a:solidFill>
-                  <a:srgbClr val="1F4E78"/>
-                </a:solidFill>
-              </a:rPr>
-              <a:t>Zero API Operational Cost: </a:t>
-            </a:r>
-            <a:r>
-              <a:rPr sz="1500">
-                <a:solidFill>
-                  <a:srgbClr val="333333"/>
-                </a:solidFill>
-              </a:rPr>
-              <a:t>Provides educational institutions with unlimited AI assistance at zero API usage fees.</a:t>
-            </a:r>
-          </a:p>
-          <a:p>
-            <a:pPr>
-              <a:spcAft>
-                <a:spcPts val="1000"/>
-              </a:spcAft>
-            </a:pPr>
-            <a:r>
-              <a:rPr b="1" sz="1500">
-                <a:solidFill>
-                  <a:srgbClr val="1F4E78"/>
-                </a:solidFill>
-              </a:rPr>
-              <a:t>Unified Learning Platform: </a:t>
-            </a:r>
-            <a:r>
-              <a:rPr sz="1500">
-                <a:solidFill>
-                  <a:srgbClr val="333333"/>
-                </a:solidFill>
-              </a:rPr>
-              <a:t>First system to integrate multi-lingual document QA, automated summarization, quizzes, and flashcards in one offline application.</a:t>
-            </a:r>
-          </a:p>
-        </p:txBody>
-      </p:sp>
-    </p:spTree>
-  </p:cSld>
-  <p:clrMapOvr>
-    <a:masterClrMapping/>
-  </p:clrMapOvr>
-</p:sld>
-</file>
-
-<file path=ppt/slides/slide11.xml><?xml version="1.0" encoding="utf-8"?>
-<p:sld xmlns:a="http://schemas.openxmlformats.org/drawingml/2006/main" xmlns:p="http://schemas.openxmlformats.org/presentationml/2006/main" xmlns:r="http://schemas.openxmlformats.org/officeDocument/2006/relationships">
-  <p:cSld>
-    <p:spTree>
-      <p:nvGrpSpPr>
-        <p:cNvPr id="1" name=""/>
-        <p:cNvGrpSpPr/>
-        <p:nvPr/>
-      </p:nvGrpSpPr>
-      <p:grpSpPr/>
-      <p:sp>
-        <p:nvSpPr>
-          <p:cNvPr id="2" name="TextBox 1"/>
-          <p:cNvSpPr txBox="1"/>
-          <p:nvPr/>
-        </p:nvSpPr>
-        <p:spPr>
-          <a:xfrm>
-            <a:off x="731520" y="457200"/>
-            <a:ext cx="10698480" cy="1097280"/>
-          </a:xfrm>
-          <a:prstGeom prst="rect">
-            <a:avLst/>
-          </a:prstGeom>
-          <a:noFill/>
-        </p:spPr>
-        <p:txBody>
-          <a:bodyPr wrap="square">
-            <a:spAutoFit/>
-          </a:bodyPr>
-          <a:lstStyle/>
-          <a:p>
-            <a:pPr>
-              <a:defRPr sz="2200" b="1">
-                <a:solidFill>
-                  <a:srgbClr val="1F4E78"/>
-                </a:solidFill>
-              </a:defRPr>
-            </a:pPr>
-            <a:r>
-              <a:t>SLIDE 11: KEY REFERENCES</a:t>
-            </a:r>
-          </a:p>
-          <a:p>
-            <a:pPr>
-              <a:defRPr sz="1300" i="1">
-                <a:solidFill>
-                  <a:srgbClr val="595959"/>
-                </a:solidFill>
-              </a:defRPr>
-            </a:pPr>
-            <a:r>
-              <a:t>Short Academic Literature Citations</a:t>
-            </a:r>
-          </a:p>
-        </p:txBody>
-      </p:sp>
-      <p:sp>
-        <p:nvSpPr>
-          <p:cNvPr id="3" name="TextBox 2"/>
-          <p:cNvSpPr txBox="1"/>
-          <p:nvPr/>
-        </p:nvSpPr>
-        <p:spPr>
-          <a:xfrm>
-            <a:off x="731520" y="1645920"/>
-            <a:ext cx="10698480" cy="4572000"/>
-          </a:xfrm>
-          <a:prstGeom prst="rect">
-            <a:avLst/>
-          </a:prstGeom>
-          <a:noFill/>
-        </p:spPr>
-        <p:txBody>
-          <a:bodyPr wrap="square">
-            <a:spAutoFit/>
-          </a:bodyPr>
-          <a:lstStyle/>
-          <a:p>
-            <a:pPr>
-              <a:spcAft>
-                <a:spcPts val="1000"/>
-              </a:spcAft>
-            </a:pPr>
-            <a:r>
-              <a:rPr b="1" sz="1500">
-                <a:solidFill>
-                  <a:srgbClr val="1F4E78"/>
-                </a:solidFill>
-              </a:rPr>
-              <a:t>Lewis et al. (2020): </a:t>
-            </a:r>
-            <a:r>
-              <a:rPr sz="1500">
-                <a:solidFill>
-                  <a:srgbClr val="333333"/>
-                </a:solidFill>
-              </a:rPr>
-              <a:t>Retrieval-Augmented Generation for Knowledge-Intensive NLP Tasks. Advances in Neural Information Processing Systems (NeurIPS).</a:t>
-            </a:r>
-          </a:p>
-          <a:p>
-            <a:pPr>
-              <a:spcAft>
-                <a:spcPts val="1000"/>
-              </a:spcAft>
-            </a:pPr>
-            <a:r>
-              <a:rPr b="1" sz="1500">
-                <a:solidFill>
-                  <a:srgbClr val="1F4E78"/>
-                </a:solidFill>
-              </a:rPr>
-              <a:t>Johnson et al. (2019): </a:t>
-            </a:r>
-            <a:r>
-              <a:rPr sz="1500">
-                <a:solidFill>
-                  <a:srgbClr val="333333"/>
-                </a:solidFill>
-              </a:rPr>
-              <a:t>Billion-scale similarity search with GPUs. IEEE Transactions on Big Data, 7(3), 535-547 (FAISS Framework).</a:t>
-            </a:r>
-          </a:p>
-          <a:p>
-            <a:pPr>
-              <a:spcAft>
-                <a:spcPts val="1000"/>
-              </a:spcAft>
-            </a:pPr>
-            <a:r>
-              <a:rPr b="1" sz="1500">
-                <a:solidFill>
-                  <a:srgbClr val="1F4E78"/>
-                </a:solidFill>
-              </a:rPr>
-              <a:t>Reimers &amp; Gurevych (2019): </a:t>
-            </a:r>
-            <a:r>
-              <a:rPr sz="1500">
-                <a:solidFill>
-                  <a:srgbClr val="333333"/>
-                </a:solidFill>
-              </a:rPr>
-              <a:t>Sentence-BERT: Sentence Embeddings using Siamese BERT-Networks. Proceedings of EMNLP.</a:t>
-            </a:r>
-          </a:p>
-          <a:p>
-            <a:pPr>
-              <a:spcAft>
-                <a:spcPts val="1000"/>
-              </a:spcAft>
-            </a:pPr>
-            <a:r>
-              <a:rPr b="1" sz="1500">
-                <a:solidFill>
-                  <a:srgbClr val="1F4E78"/>
-                </a:solidFill>
-              </a:rPr>
-              <a:t>Vaswani et al. (2017): </a:t>
-            </a:r>
-            <a:r>
-              <a:rPr sz="1500">
-                <a:solidFill>
-                  <a:srgbClr val="333333"/>
-                </a:solidFill>
-              </a:rPr>
-              <a:t>Attention Is All You Need. Advances in Neural Information Processing Systems (Transformer Architecture).</a:t>
-            </a:r>
-          </a:p>
-        </p:txBody>
-      </p:sp>
-    </p:spTree>
-  </p:cSld>
-  <p:clrMapOvr>
-    <a:masterClrMapping/>
-  </p:clrMapOvr>
-</p:sld>
-</file>
-
-<file path=ppt/slides/slide12.xml><?xml version="1.0" encoding="utf-8"?>
-<p:sld xmlns:a="http://schemas.openxmlformats.org/drawingml/2006/main" xmlns:p="http://schemas.openxmlformats.org/presentationml/2006/main" xmlns:r="http://schemas.openxmlformats.org/officeDocument/2006/relationships">
-  <p:cSld>
-    <p:spTree>
-      <p:nvGrpSpPr>
-        <p:cNvPr id="1" name=""/>
-        <p:cNvGrpSpPr/>
-        <p:nvPr/>
-      </p:nvGrpSpPr>
-      <p:grpSpPr/>
-      <p:sp>
-        <p:nvSpPr>
-          <p:cNvPr id="2" name="TextBox 1"/>
-          <p:cNvSpPr txBox="1"/>
-          <p:nvPr/>
-        </p:nvSpPr>
-        <p:spPr>
-          <a:xfrm>
-            <a:off x="731520" y="457200"/>
-            <a:ext cx="10698480" cy="1097280"/>
-          </a:xfrm>
-          <a:prstGeom prst="rect">
-            <a:avLst/>
-          </a:prstGeom>
-          <a:noFill/>
-        </p:spPr>
-        <p:txBody>
-          <a:bodyPr wrap="square">
-            <a:spAutoFit/>
-          </a:bodyPr>
-          <a:lstStyle/>
-          <a:p>
-            <a:pPr>
-              <a:defRPr sz="2200" b="1">
-                <a:solidFill>
-                  <a:srgbClr val="1F4E78"/>
-                </a:solidFill>
-              </a:defRPr>
-            </a:pPr>
-            <a:r>
-              <a:t>SLIDE 12: RECOMMENDATIONS &amp; FUTURE WORK</a:t>
-            </a:r>
-          </a:p>
-          <a:p>
-            <a:pPr>
-              <a:defRPr sz="1300" i="1">
-                <a:solidFill>
-                  <a:srgbClr val="595959"/>
-                </a:solidFill>
-              </a:defRPr>
-            </a:pPr>
-            <a:r>
-              <a:t>Future Extensions &amp; Defense Panel Q&amp;A</a:t>
-            </a:r>
-          </a:p>
-        </p:txBody>
-      </p:sp>
-      <p:sp>
-        <p:nvSpPr>
-          <p:cNvPr id="3" name="TextBox 2"/>
-          <p:cNvSpPr txBox="1"/>
-          <p:nvPr/>
-        </p:nvSpPr>
-        <p:spPr>
-          <a:xfrm>
-            <a:off x="731520" y="1645920"/>
-            <a:ext cx="10698480" cy="4572000"/>
-          </a:xfrm>
-          <a:prstGeom prst="rect">
-            <a:avLst/>
-          </a:prstGeom>
-          <a:noFill/>
-        </p:spPr>
-        <p:txBody>
-          <a:bodyPr wrap="square">
-            <a:spAutoFit/>
-          </a:bodyPr>
-          <a:lstStyle/>
-          <a:p>
-            <a:pPr>
-              <a:spcAft>
-                <a:spcPts val="1000"/>
-              </a:spcAft>
-            </a:pPr>
-            <a:r>
-              <a:rPr b="1" sz="1500">
-                <a:solidFill>
-                  <a:srgbClr val="1F4E78"/>
-                </a:solidFill>
-              </a:rPr>
-              <a:t>Recommendation 1 (OCR Integration): </a:t>
-            </a:r>
-            <a:r>
-              <a:rPr sz="1500">
-                <a:solidFill>
-                  <a:srgbClr val="333333"/>
-                </a:solidFill>
-              </a:rPr>
-              <a:t>Incorporate Optical Character Recognition (Tesseract/PaddleOCR) for scanned paper documents.</a:t>
-            </a:r>
-          </a:p>
-          <a:p>
-            <a:pPr>
-              <a:spcAft>
-                <a:spcPts val="1000"/>
-              </a:spcAft>
-            </a:pPr>
-            <a:r>
-              <a:rPr b="1" sz="1500">
-                <a:solidFill>
-                  <a:srgbClr val="1F4E78"/>
-                </a:solidFill>
-              </a:rPr>
-              <a:t>Recommendation 2 (Mobile App): </a:t>
-            </a:r>
-            <a:r>
-              <a:rPr sz="1500">
-                <a:solidFill>
-                  <a:srgbClr val="333333"/>
-                </a:solidFill>
-              </a:rPr>
-              <a:t>Develop a lightweight cross-platform mobile application powered by ONNX runtime.</a:t>
-            </a:r>
-          </a:p>
-          <a:p>
-            <a:pPr>
-              <a:spcAft>
-                <a:spcPts val="1000"/>
-              </a:spcAft>
-            </a:pPr>
-            <a:r>
-              <a:rPr b="1" sz="1500">
-                <a:solidFill>
-                  <a:srgbClr val="1F4E78"/>
-                </a:solidFill>
-              </a:rPr>
-              <a:t>Recommendation 3 (Voice Assistant): </a:t>
-            </a:r>
-            <a:r>
-              <a:rPr sz="1500">
-                <a:solidFill>
-                  <a:srgbClr val="333333"/>
-                </a:solidFill>
-              </a:rPr>
-              <a:t>Integrate local Whisper Speech-to-Text for hands-free voice interaction.</a:t>
-            </a:r>
-          </a:p>
-          <a:p>
-            <a:pPr>
-              <a:spcAft>
-                <a:spcPts val="1000"/>
-              </a:spcAft>
-            </a:pPr>
-            <a:r>
-              <a:rPr b="1" sz="1500">
-                <a:solidFill>
-                  <a:srgbClr val="1F4E78"/>
-                </a:solidFill>
-              </a:rPr>
-              <a:t>Acknowledgement &amp; Q&amp;A: </a:t>
-            </a:r>
-            <a:r>
-              <a:rPr sz="1500">
-                <a:solidFill>
-                  <a:srgbClr val="333333"/>
-                </a:solidFill>
-              </a:rPr>
-              <a:t>Thank you for your time and attention. I am now open to questions from the honorable panel.</a:t>
             </a:r>
           </a:p>
         </p:txBody>
@@ -4075,7 +3531,7 @@
               </a:defRPr>
             </a:pPr>
             <a:r>
-              <a:t>SLIDE 3: BACKGROUND OF THE STUDY &amp; PROBLEM STATEMENT</a:t>
+              <a:t>SLIDE 3: AIM AND OBJECTIVES OF THE SYSTEM</a:t>
             </a:r>
           </a:p>
           <a:p>
@@ -4087,7 +3543,7 @@
               </a:defRPr>
             </a:pPr>
             <a:r>
-              <a:t>Motivation and Challenges in Academic Document Analysis</a:t>
+              <a:t>System Goals and Functional Capabilities</a:t>
             </a:r>
           </a:p>
         </p:txBody>
@@ -4125,7 +3581,7 @@
                   <a:srgbClr val="1F4E78"/>
                 </a:solidFill>
               </a:rPr>
-              <a:t>Manual Inefficiency: </a:t>
+              <a:t>Overall Aim: </a:t>
             </a:r>
             <a:r>
               <a:rPr sz="1500">
@@ -4133,7 +3589,7 @@
                   <a:srgbClr val="333333"/>
                 </a:solidFill>
               </a:rPr>
-              <a:t>Manual reading and keyword searching across extensive PDF/DOCX documents lead to information oversight and context loss.</a:t>
+              <a:t>Develop a high-speed, secure, offline Intelligent Document Analysis and Learning Assistant System using local RAG.</a:t>
             </a:r>
           </a:p>
           <a:p>
@@ -4148,7 +3604,7 @@
                   <a:srgbClr val="1F4E78"/>
                 </a:solidFill>
               </a:rPr>
-              <a:t>Cloud Data Sovereignty: </a:t>
+              <a:t>Objective 1 - Multi-format Parsing: </a:t>
             </a:r>
             <a:r>
               <a:rPr sz="1500">
@@ -4156,7 +3612,7 @@
                   <a:srgbClr val="333333"/>
                 </a:solidFill>
               </a:rPr>
-              <a:t>Sending private research or institutional data to external cloud APIs violates data sovereignty and incurs continuous usage fees.</a:t>
+              <a:t>Support seamless text ingestion from PDF, DOCX, TXT, and CSV files with page/row tracking.</a:t>
             </a:r>
           </a:p>
           <a:p>
@@ -4171,7 +3627,7 @@
                   <a:srgbClr val="1F4E78"/>
                 </a:solidFill>
               </a:rPr>
-              <a:t>CPU Latency Bottleneck: </a:t>
+              <a:t>Objective 2 - Local RAG QA: </a:t>
             </a:r>
             <a:r>
               <a:rPr sz="1500">
@@ -4179,7 +3635,7 @@
                   <a:srgbClr val="333333"/>
                 </a:solidFill>
               </a:rPr>
-              <a:t>Running local LLMs directly on standard CPU hardware suffers from high prefill latency during context processing.</a:t>
+              <a:t>Provide context-grounded question answering using Ollama local models (Qwen 2.5 / Gemma 2).</a:t>
             </a:r>
           </a:p>
           <a:p>
@@ -4194,7 +3650,7 @@
                   <a:srgbClr val="1F4E78"/>
                 </a:solidFill>
               </a:rPr>
-              <a:t>Integrated Learning Support: </a:t>
+              <a:t>Objective 3 - Study Mode Tools: </a:t>
             </a:r>
             <a:r>
               <a:rPr sz="1500">
@@ -4202,7 +3658,30 @@
                   <a:srgbClr val="333333"/>
                 </a:solidFill>
               </a:rPr>
-              <a:t>Existing tools lack a single platform combining document QA with Study Mode features (Summaries, Quizzes, Flashcards).</a:t>
+              <a:t>Generate structured summaries, multiple-choice quizzes, and interactive study flashcards offline.</a:t>
+            </a:r>
+          </a:p>
+          <a:p>
+            <a:pPr>
+              <a:spcAft>
+                <a:spcPts val="1000"/>
+              </a:spcAft>
+            </a:pPr>
+            <a:r>
+              <a:rPr b="1" sz="1500">
+                <a:solidFill>
+                  <a:srgbClr val="1F4E78"/>
+                </a:solidFill>
+              </a:rPr>
+              <a:t>Objective 4 - Grounding Shield &amp; Multilingual: </a:t>
+            </a:r>
+            <a:r>
+              <a:rPr sz="1500">
+                <a:solidFill>
+                  <a:srgbClr val="333333"/>
+                </a:solidFill>
+              </a:rPr>
+              <a:t>Enforce a 0.40 similarity threshold to block out-of-scope hallucinations and support Hausa cross-lingual QA.</a:t>
             </a:r>
           </a:p>
         </p:txBody>
@@ -4255,7 +3734,7 @@
               </a:defRPr>
             </a:pPr>
             <a:r>
-              <a:t>SLIDE 4: AIM AND OBJECTIVES OF THE SYSTEM</a:t>
+              <a:t>SLIDE 4: SYSTEM DEVELOPMENT LIFE CYCLE (SDLC) &amp; METHODOLOGY</a:t>
             </a:r>
           </a:p>
           <a:p>
@@ -4267,7 +3746,7 @@
               </a:defRPr>
             </a:pPr>
             <a:r>
-              <a:t>System Goals and Functional Capabilities</a:t>
+              <a:t>Prototyping Methodology &amp; Phase Execution</a:t>
             </a:r>
           </a:p>
         </p:txBody>
@@ -4305,7 +3784,7 @@
                   <a:srgbClr val="1F4E78"/>
                 </a:solidFill>
               </a:rPr>
-              <a:t>Overall Aim: </a:t>
+              <a:t>What is the Methodology? </a:t>
             </a:r>
             <a:r>
               <a:rPr sz="1500">
@@ -4313,7 +3792,7 @@
                   <a:srgbClr val="333333"/>
                 </a:solidFill>
               </a:rPr>
-              <a:t>Develop a high-speed, secure, offline Intelligent Document Analysis and Learning Assistant System using local RAG.</a:t>
+              <a:t>Prototyping SDLC — an iterative 4-phase software engineering model chosen over rigid Waterfall for continuous experimental refinement.</a:t>
             </a:r>
           </a:p>
           <a:p>
@@ -4328,7 +3807,7 @@
                   <a:srgbClr val="1F4E78"/>
                 </a:solidFill>
               </a:rPr>
-              <a:t>Objective 1 - Multi-format Parsing: </a:t>
+              <a:t>Phase 1 - Requirements &amp; Analysis: </a:t>
             </a:r>
             <a:r>
               <a:rPr sz="1500">
@@ -4336,7 +3815,7 @@
                   <a:srgbClr val="333333"/>
                 </a:solidFill>
               </a:rPr>
-              <a:t>Support seamless text ingestion from PDF, DOCX, TXT, and CSV files with page/row tracking.</a:t>
+              <a:t>Defined offline data privacy requirements, multi-format ingestion needs (PDF, DOCX, CSV), and local CPU hardware latency constraints.</a:t>
             </a:r>
           </a:p>
           <a:p>
@@ -4351,7 +3830,7 @@
                   <a:srgbClr val="1F4E78"/>
                 </a:solidFill>
               </a:rPr>
-              <a:t>Objective 2 - Local RAG QA: </a:t>
+              <a:t>Phase 2 - Quick Prototype Design: </a:t>
             </a:r>
             <a:r>
               <a:rPr sz="1500">
@@ -4359,7 +3838,7 @@
                   <a:srgbClr val="333333"/>
                 </a:solidFill>
               </a:rPr>
-              <a:t>Provide context-grounded question answering using Ollama local models (Qwen 2.5 / Gemma 2).</a:t>
+              <a:t>Built initial Next.js single-page UI, FastAPI backend services, SQLite database schemas, and FAISS vector indexing.</a:t>
             </a:r>
           </a:p>
           <a:p>
@@ -4374,7 +3853,7 @@
                   <a:srgbClr val="1F4E78"/>
                 </a:solidFill>
               </a:rPr>
-              <a:t>Objective 3 - Study Mode Tools: </a:t>
+              <a:t>Phase 3 - Iterative Refinement &amp; Benchmarking: </a:t>
             </a:r>
             <a:r>
               <a:rPr sz="1500">
@@ -4382,7 +3861,7 @@
                   <a:srgbClr val="333333"/>
                 </a:solidFill>
               </a:rPr>
-              <a:t>Generate structured summaries, multiple-choice quizzes, and interactive study flashcards offline.</a:t>
+              <a:t>Iteratively benchmarked chunk sizes (finding 1000 chars + 150 overlap optimal) and created the 0.00s deterministic query classifier.</a:t>
             </a:r>
           </a:p>
           <a:p>
@@ -4397,7 +3876,7 @@
                   <a:srgbClr val="1F4E78"/>
                 </a:solidFill>
               </a:rPr>
-              <a:t>Objective 4 - Grounding Shield &amp; Multilingual: </a:t>
+              <a:t>Phase 4 - Final System Evaluation &amp; Testing: </a:t>
             </a:r>
             <a:r>
               <a:rPr sz="1500">
@@ -4405,7 +3884,7 @@
                   <a:srgbClr val="333333"/>
                 </a:solidFill>
               </a:rPr>
-              <a:t>Enforce a 0.40 similarity threshold to block out-of-scope hallucinations and support Hausa cross-lingual QA.</a:t>
+              <a:t>Validated out-of-scope grounding shield accuracy (threshold 0.40), Hausa query detection, and full offline execution.</a:t>
             </a:r>
           </a:p>
         </p:txBody>
@@ -4458,7 +3937,7 @@
               </a:defRPr>
             </a:pPr>
             <a:r>
-              <a:t>SLIDE 5: SDLC METHODOLOGY &amp; WHY PROTOTYPING WAS CHOSEN</a:t>
+              <a:t>SLIDE 5: TESTING AND BENCHMARK RESULTS</a:t>
             </a:r>
           </a:p>
           <a:p>
@@ -4470,7 +3949,7 @@
               </a:defRPr>
             </a:pPr>
             <a:r>
-              <a:t>Software Development Life Cycle &amp; Architectural Rationale</a:t>
+              <a:t>Empirical Performance Evaluation &amp; Latency Gains</a:t>
             </a:r>
           </a:p>
         </p:txBody>
@@ -4508,7 +3987,7 @@
                   <a:srgbClr val="1F4E78"/>
                 </a:solidFill>
               </a:rPr>
-              <a:t>Methodology Adopted: </a:t>
+              <a:t>RAG Execution Latency: </a:t>
             </a:r>
             <a:r>
               <a:rPr sz="1500">
@@ -4516,7 +3995,7 @@
                   <a:srgbClr val="333333"/>
                 </a:solidFill>
               </a:rPr>
-              <a:t>Prototyping Software Development Life Cycle (SDLC) was selected over traditional Waterfall.</a:t>
+              <a:t>Overall RAG execution time on CPU reduced by 48.57% (from 71.69s down to 36.87s).</a:t>
             </a:r>
           </a:p>
           <a:p>
@@ -4531,7 +4010,7 @@
                   <a:srgbClr val="1F4E78"/>
                 </a:solidFill>
               </a:rPr>
-              <a:t>Why Prototyping? (Reason 1 - Iterative Chunking): </a:t>
+              <a:t>Classifier Speedup: </a:t>
             </a:r>
             <a:r>
               <a:rPr sz="1500">
@@ -4539,7 +4018,7 @@
                   <a:srgbClr val="333333"/>
                 </a:solidFill>
               </a:rPr>
-              <a:t>Allowed benchmarking different segment sizes to discover the optimal 1000-char chunking with 150-char overlap.</a:t>
+              <a:t>Deterministic query router reduced intent classification latency from 12.4s down to 0.00s.</a:t>
             </a:r>
           </a:p>
           <a:p>
@@ -4554,7 +4033,7 @@
                   <a:srgbClr val="1F4E78"/>
                 </a:solidFill>
               </a:rPr>
-              <a:t>Why Prototyping? (Reason 2 - UI Refinement): </a:t>
+              <a:t>Grounding Shield Accuracy: </a:t>
             </a:r>
             <a:r>
               <a:rPr sz="1500">
@@ -4562,7 +4041,7 @@
                   <a:srgbClr val="333333"/>
                 </a:solidFill>
               </a:rPr>
-              <a:t>Rapidly testing and refining the collapsible sidebar, floating overlay, and Study Mode dashboards with direct feedback.</a:t>
+              <a:t>0.40 cosine similarity threshold effectively blocked 100% of out-of-scope hallucinated queries.</a:t>
             </a:r>
           </a:p>
           <a:p>
@@ -4577,7 +4056,7 @@
                   <a:srgbClr val="1F4E78"/>
                 </a:solidFill>
               </a:rPr>
-              <a:t>Why Prototyping? (Reason 3 - Latency Optimization): </a:t>
+              <a:t>System Reliability: </a:t>
             </a:r>
             <a:r>
               <a:rPr sz="1500">
@@ -4585,7 +4064,7 @@
                   <a:srgbClr val="333333"/>
                 </a:solidFill>
               </a:rPr>
-              <a:t>Enabled benchmark-driven iterations that introduced the 0.00s deterministic query classifier and out-of-scope grounding shield.</a:t>
+              <a:t>All primary modules (Auth, Upload, QA, Summary, Quiz, Flashcards) passed automated verification.</a:t>
             </a:r>
           </a:p>
         </p:txBody>
@@ -4638,7 +4117,7 @@
               </a:defRPr>
             </a:pPr>
             <a:r>
-              <a:t>SLIDE 6: SYSTEM ARCHITECTURE AND DATA FLOW</a:t>
+              <a:t>SLIDE 6: CONCLUSION AND CONTRIBUTIONS</a:t>
             </a:r>
           </a:p>
           <a:p>
@@ -4650,7 +4129,7 @@
               </a:defRPr>
             </a:pPr>
             <a:r>
-              <a:t>End-to-End Pipeline &amp; Component Integration</a:t>
+              <a:t>Summary of Accomplishments and Significance</a:t>
             </a:r>
           </a:p>
         </p:txBody>
@@ -4688,7 +4167,7 @@
                   <a:srgbClr val="1F4E78"/>
                 </a:solidFill>
               </a:rPr>
-              <a:t>User Interaction Layer: </a:t>
+              <a:t>Summary: </a:t>
             </a:r>
             <a:r>
               <a:rPr sz="1500">
@@ -4696,7 +4175,7 @@
                   <a:srgbClr val="333333"/>
                 </a:solidFill>
               </a:rPr>
-              <a:t>Next.js 16 responsive SPA interface communicating with backend services via REST APIs.</a:t>
+              <a:t>AuraQA successfully proves that high-performance, secure AI document intelligence is achievable locally on CPU hardware.</a:t>
             </a:r>
           </a:p>
           <a:p>
@@ -4711,7 +4190,7 @@
                   <a:srgbClr val="1F4E78"/>
                 </a:solidFill>
               </a:rPr>
-              <a:t>Ingestion &amp; Extraction Layer: </a:t>
+              <a:t>Data Sovereignty: </a:t>
             </a:r>
             <a:r>
               <a:rPr sz="1500">
@@ -4719,7 +4198,7 @@
                   <a:srgbClr val="333333"/>
                 </a:solidFill>
               </a:rPr>
-              <a:t>Multi-format text extraction (pdf, docx, csv, txt) split into overlapping semantic segments.</a:t>
+              <a:t>Eliminates all third-party cloud data transmission, ensuring 100% user data privacy.</a:t>
             </a:r>
           </a:p>
           <a:p>
@@ -4734,7 +4213,7 @@
                   <a:srgbClr val="1F4E78"/>
                 </a:solidFill>
               </a:rPr>
-              <a:t>Dense Vector Indexing: </a:t>
+              <a:t>Zero API Operational Cost: </a:t>
             </a:r>
             <a:r>
               <a:rPr sz="1500">
@@ -4742,7 +4221,7 @@
                   <a:srgbClr val="333333"/>
                 </a:solidFill>
               </a:rPr>
-              <a:t>paraphrase-multilingual-MiniLM-L12-v2 model maps text chunks into FAISS FlatIP index.</a:t>
+              <a:t>Provides educational institutions with unlimited AI assistance at zero API usage fees.</a:t>
             </a:r>
           </a:p>
           <a:p>
@@ -4757,7 +4236,7 @@
                   <a:srgbClr val="1F4E78"/>
                 </a:solidFill>
               </a:rPr>
-              <a:t>Intent &amp; Search Engine: </a:t>
+              <a:t>Unified Learning Platform: </a:t>
             </a:r>
             <a:r>
               <a:rPr sz="1500">
@@ -4765,30 +4244,7 @@
                   <a:srgbClr val="333333"/>
                 </a:solidFill>
               </a:rPr>
-              <a:t>Deterministic rule-based query classifier routes requests in 0.00s and retrieves top matching vectors.</a:t>
-            </a:r>
-          </a:p>
-          <a:p>
-            <a:pPr>
-              <a:spcAft>
-                <a:spcPts val="1000"/>
-              </a:spcAft>
-            </a:pPr>
-            <a:r>
-              <a:rPr b="1" sz="1500">
-                <a:solidFill>
-                  <a:srgbClr val="1F4E78"/>
-                </a:solidFill>
-              </a:rPr>
-              <a:t>Local LLM Generation: </a:t>
-            </a:r>
-            <a:r>
-              <a:rPr sz="1500">
-                <a:solidFill>
-                  <a:srgbClr val="333333"/>
-                </a:solidFill>
-              </a:rPr>
-              <a:t>Ollama engine executes Qwen 2.5 / Gemma 2 locally to stream grounded answers.</a:t>
+              <a:t>First system to integrate multi-lingual document QA, automated summarization, quizzes, and flashcards in one offline application.</a:t>
             </a:r>
           </a:p>
         </p:txBody>
@@ -4841,7 +4297,7 @@
               </a:defRPr>
             </a:pPr>
             <a:r>
-              <a:t>SLIDE 7: TECHNOLOGIES USED</a:t>
+              <a:t>SLIDE 7: KEY REFERENCES</a:t>
             </a:r>
           </a:p>
           <a:p>
@@ -4853,7 +4309,7 @@
               </a:defRPr>
             </a:pPr>
             <a:r>
-              <a:t>Software Stack and Framework Specifications</a:t>
+              <a:t>Short Academic Literature Citations</a:t>
             </a:r>
           </a:p>
         </p:txBody>
@@ -4891,7 +4347,7 @@
                   <a:srgbClr val="1F4E78"/>
                 </a:solidFill>
               </a:rPr>
-              <a:t>Frontend Framework: </a:t>
+              <a:t>Lewis et al. (2020): </a:t>
             </a:r>
             <a:r>
               <a:rPr sz="1500">
@@ -4899,7 +4355,7 @@
                   <a:srgbClr val="333333"/>
                 </a:solidFill>
               </a:rPr>
-              <a:t>Next.js 16 (React 19) + Tailwind CSS + Lucide Icons.</a:t>
+              <a:t>Retrieval-Augmented Generation for Knowledge-Intensive NLP Tasks. Advances in Neural Information Processing Systems (NeurIPS).</a:t>
             </a:r>
           </a:p>
           <a:p>
@@ -4914,7 +4370,7 @@
                   <a:srgbClr val="1F4E78"/>
                 </a:solidFill>
               </a:rPr>
-              <a:t>Backend Engine: </a:t>
+              <a:t>Johnson et al. (2019): </a:t>
             </a:r>
             <a:r>
               <a:rPr sz="1500">
@@ -4922,7 +4378,7 @@
                   <a:srgbClr val="333333"/>
                 </a:solidFill>
               </a:rPr>
-              <a:t>FastAPI (Python 3.10+) + Uvicorn ASGI Server.</a:t>
+              <a:t>Billion-scale similarity search with GPUs. IEEE Transactions on Big Data, 7(3), 535-547 (FAISS Framework).</a:t>
             </a:r>
           </a:p>
           <a:p>
@@ -4937,7 +4393,7 @@
                   <a:srgbClr val="1F4E78"/>
                 </a:solidFill>
               </a:rPr>
-              <a:t>Relational Database: </a:t>
+              <a:t>Reimers &amp; Gurevych (2019): </a:t>
             </a:r>
             <a:r>
               <a:rPr sz="1500">
@@ -4945,7 +4401,7 @@
                   <a:srgbClr val="333333"/>
                 </a:solidFill>
               </a:rPr>
-              <a:t>SQLite (SQLAlchemy ORM for Users, Chats, Documents, Quizzes, Flashcards).</a:t>
+              <a:t>Sentence-BERT: Sentence Embeddings using Siamese BERT-Networks. Proceedings of EMNLP.</a:t>
             </a:r>
           </a:p>
           <a:p>
@@ -4960,7 +4416,7 @@
                   <a:srgbClr val="1F4E78"/>
                 </a:solidFill>
               </a:rPr>
-              <a:t>Vector Store: </a:t>
+              <a:t>Vaswani et al. (2017): </a:t>
             </a:r>
             <a:r>
               <a:rPr sz="1500">
@@ -4968,30 +4424,7 @@
                   <a:srgbClr val="333333"/>
                 </a:solidFill>
               </a:rPr>
-              <a:t>FAISS (Facebook AI Similarity Search) with IndexIDMap and Inner Product quantizer.</a:t>
-            </a:r>
-          </a:p>
-          <a:p>
-            <a:pPr>
-              <a:spcAft>
-                <a:spcPts val="1000"/>
-              </a:spcAft>
-            </a:pPr>
-            <a:r>
-              <a:rPr b="1" sz="1500">
-                <a:solidFill>
-                  <a:srgbClr val="1F4E78"/>
-                </a:solidFill>
-              </a:rPr>
-              <a:t>AI Embeddings &amp; LLM: </a:t>
-            </a:r>
-            <a:r>
-              <a:rPr sz="1500">
-                <a:solidFill>
-                  <a:srgbClr val="333333"/>
-                </a:solidFill>
-              </a:rPr>
-              <a:t>Sentence Transformers + Ollama Local LLM Runner (Qwen 2.5 0.5B / Gemma 2 2B).</a:t>
+              <a:t>Attention Is All You Need. Advances in Neural Information Processing Systems (Transformer Architecture).</a:t>
             </a:r>
           </a:p>
         </p:txBody>
@@ -5044,7 +4477,7 @@
               </a:defRPr>
             </a:pPr>
             <a:r>
-              <a:t>SLIDE 8: SYSTEM DEMONSTRATION &amp; CORE MODULES</a:t>
+              <a:t>SLIDE 8: RECOMMENDATIONS &amp; FUTURE WORK</a:t>
             </a:r>
           </a:p>
           <a:p>
@@ -5056,7 +4489,7 @@
               </a:defRPr>
             </a:pPr>
             <a:r>
-              <a:t>Feature Breakdown and User Experience</a:t>
+              <a:t>Future Extensions &amp; Defense Panel Q&amp;A</a:t>
             </a:r>
           </a:p>
         </p:txBody>
@@ -5094,7 +4527,7 @@
                   <a:srgbClr val="1F4E78"/>
                 </a:solidFill>
               </a:rPr>
-              <a:t>Authentication Module: </a:t>
+              <a:t>Recommendation 1 (OCR Integration): </a:t>
             </a:r>
             <a:r>
               <a:rPr sz="1500">
@@ -5102,7 +4535,7 @@
                   <a:srgbClr val="333333"/>
                 </a:solidFill>
               </a:rPr>
-              <a:t>Secure JWT token authentication with bcrypt password hashing.</a:t>
+              <a:t>Incorporate Optical Character Recognition (Tesseract/PaddleOCR) for scanned paper documents.</a:t>
             </a:r>
           </a:p>
           <a:p>
@@ -5117,7 +4550,7 @@
                   <a:srgbClr val="1F4E78"/>
                 </a:solidFill>
               </a:rPr>
-              <a:t>Document Library &amp; Upload: </a:t>
+              <a:t>Recommendation 2 (Mobile App): </a:t>
             </a:r>
             <a:r>
               <a:rPr sz="1500">
@@ -5125,7 +4558,7 @@
                   <a:srgbClr val="333333"/>
                 </a:solidFill>
               </a:rPr>
-              <a:t>Drag-and-drop file ingestion with automatic language detection.</a:t>
+              <a:t>Develop a lightweight cross-platform mobile application powered by ONNX runtime.</a:t>
             </a:r>
           </a:p>
           <a:p>
@@ -5140,7 +4573,7 @@
                   <a:srgbClr val="1F4E78"/>
                 </a:solidFill>
               </a:rPr>
-              <a:t>Chat Interface: </a:t>
+              <a:t>Recommendation 3 (Voice Assistant): </a:t>
             </a:r>
             <a:r>
               <a:rPr sz="1500">
@@ -5148,7 +4581,7 @@
                   <a:srgbClr val="333333"/>
                 </a:solidFill>
               </a:rPr>
-              <a:t>Collapsible Gemini-style sidebar, floating overlay input, and streaming response viewport.</a:t>
+              <a:t>Integrate local Whisper Speech-to-Text for hands-free voice interaction.</a:t>
             </a:r>
           </a:p>
           <a:p>
@@ -5163,7 +4596,7 @@
                   <a:srgbClr val="1F4E78"/>
                 </a:solidFill>
               </a:rPr>
-              <a:t>Study Mode Tools: </a:t>
+              <a:t>Acknowledgement &amp; Q&amp;A: </a:t>
             </a:r>
             <a:r>
               <a:rPr sz="1500">
@@ -5171,210 +4604,7 @@
                   <a:srgbClr val="333333"/>
                 </a:solidFill>
               </a:rPr>
-              <a:t>Instant automated summary extraction, multiple-choice quiz generator, and interactive flashcards.</a:t>
-            </a:r>
-          </a:p>
-          <a:p>
-            <a:pPr>
-              <a:spcAft>
-                <a:spcPts val="1000"/>
-              </a:spcAft>
-            </a:pPr>
-            <a:r>
-              <a:rPr b="1" sz="1500">
-                <a:solidFill>
-                  <a:srgbClr val="1F4E78"/>
-                </a:solidFill>
-              </a:rPr>
-              <a:t>Hausa Multilingual Support: </a:t>
-            </a:r>
-            <a:r>
-              <a:rPr sz="1500">
-                <a:solidFill>
-                  <a:srgbClr val="333333"/>
-                </a:solidFill>
-              </a:rPr>
-              <a:t>Native Hausa query detection (`ha`) with Hausa out-of-scope warning prefixes.</a:t>
-            </a:r>
-          </a:p>
-        </p:txBody>
-      </p:sp>
-    </p:spTree>
-  </p:cSld>
-  <p:clrMapOvr>
-    <a:masterClrMapping/>
-  </p:clrMapOvr>
-</p:sld>
-</file>
-
-<file path=ppt/slides/slide9.xml><?xml version="1.0" encoding="utf-8"?>
-<p:sld xmlns:a="http://schemas.openxmlformats.org/drawingml/2006/main" xmlns:p="http://schemas.openxmlformats.org/presentationml/2006/main" xmlns:r="http://schemas.openxmlformats.org/officeDocument/2006/relationships">
-  <p:cSld>
-    <p:spTree>
-      <p:nvGrpSpPr>
-        <p:cNvPr id="1" name=""/>
-        <p:cNvGrpSpPr/>
-        <p:nvPr/>
-      </p:nvGrpSpPr>
-      <p:grpSpPr/>
-      <p:sp>
-        <p:nvSpPr>
-          <p:cNvPr id="2" name="TextBox 1"/>
-          <p:cNvSpPr txBox="1"/>
-          <p:nvPr/>
-        </p:nvSpPr>
-        <p:spPr>
-          <a:xfrm>
-            <a:off x="731520" y="457200"/>
-            <a:ext cx="10698480" cy="1097280"/>
-          </a:xfrm>
-          <a:prstGeom prst="rect">
-            <a:avLst/>
-          </a:prstGeom>
-          <a:noFill/>
-        </p:spPr>
-        <p:txBody>
-          <a:bodyPr wrap="square">
-            <a:spAutoFit/>
-          </a:bodyPr>
-          <a:lstStyle/>
-          <a:p>
-            <a:pPr>
-              <a:defRPr sz="2200" b="1">
-                <a:solidFill>
-                  <a:srgbClr val="1F4E78"/>
-                </a:solidFill>
-              </a:defRPr>
-            </a:pPr>
-            <a:r>
-              <a:t>SLIDE 9: TESTING AND BENCHMARK RESULTS</a:t>
-            </a:r>
-          </a:p>
-          <a:p>
-            <a:pPr>
-              <a:defRPr sz="1300" i="1">
-                <a:solidFill>
-                  <a:srgbClr val="595959"/>
-                </a:solidFill>
-              </a:defRPr>
-            </a:pPr>
-            <a:r>
-              <a:t>Empirical Performance Evaluation &amp; Latency Gains</a:t>
-            </a:r>
-          </a:p>
-        </p:txBody>
-      </p:sp>
-      <p:sp>
-        <p:nvSpPr>
-          <p:cNvPr id="3" name="TextBox 2"/>
-          <p:cNvSpPr txBox="1"/>
-          <p:nvPr/>
-        </p:nvSpPr>
-        <p:spPr>
-          <a:xfrm>
-            <a:off x="731520" y="1645920"/>
-            <a:ext cx="10698480" cy="4572000"/>
-          </a:xfrm>
-          <a:prstGeom prst="rect">
-            <a:avLst/>
-          </a:prstGeom>
-          <a:noFill/>
-        </p:spPr>
-        <p:txBody>
-          <a:bodyPr wrap="square">
-            <a:spAutoFit/>
-          </a:bodyPr>
-          <a:lstStyle/>
-          <a:p>
-            <a:pPr>
-              <a:spcAft>
-                <a:spcPts val="1000"/>
-              </a:spcAft>
-            </a:pPr>
-            <a:r>
-              <a:rPr b="1" sz="1500">
-                <a:solidFill>
-                  <a:srgbClr val="1F4E78"/>
-                </a:solidFill>
-              </a:rPr>
-              <a:t>RAG Execution Latency: </a:t>
-            </a:r>
-            <a:r>
-              <a:rPr sz="1500">
-                <a:solidFill>
-                  <a:srgbClr val="333333"/>
-                </a:solidFill>
-              </a:rPr>
-              <a:t>Overall RAG execution time on CPU reduced by 48.57% (from 71.69s down to 36.87s).</a:t>
-            </a:r>
-          </a:p>
-          <a:p>
-            <a:pPr>
-              <a:spcAft>
-                <a:spcPts val="1000"/>
-              </a:spcAft>
-            </a:pPr>
-            <a:r>
-              <a:rPr b="1" sz="1500">
-                <a:solidFill>
-                  <a:srgbClr val="1F4E78"/>
-                </a:solidFill>
-              </a:rPr>
-              <a:t>Classifier Speedup: </a:t>
-            </a:r>
-            <a:r>
-              <a:rPr sz="1500">
-                <a:solidFill>
-                  <a:srgbClr val="333333"/>
-                </a:solidFill>
-              </a:rPr>
-              <a:t>Deterministic query router reduced intent classification latency from 12.4s down to 0.00s.</a:t>
-            </a:r>
-          </a:p>
-          <a:p>
-            <a:pPr>
-              <a:spcAft>
-                <a:spcPts val="1000"/>
-              </a:spcAft>
-            </a:pPr>
-            <a:r>
-              <a:rPr b="1" sz="1500">
-                <a:solidFill>
-                  <a:srgbClr val="1F4E78"/>
-                </a:solidFill>
-              </a:rPr>
-              <a:t>Grounding Shield Accuracy: </a:t>
-            </a:r>
-            <a:r>
-              <a:rPr sz="1500">
-                <a:solidFill>
-                  <a:srgbClr val="333333"/>
-                </a:solidFill>
-              </a:rPr>
-              <a:t>0.40 cosine similarity threshold effectively blocked 100% of out-of-scope hallucinated queries.</a:t>
-            </a:r>
-          </a:p>
-          <a:p>
-            <a:pPr>
-              <a:spcAft>
-                <a:spcPts val="1000"/>
-              </a:spcAft>
-            </a:pPr>
-            <a:r>
-              <a:rPr b="1" sz="1500">
-                <a:solidFill>
-                  <a:srgbClr val="1F4E78"/>
-                </a:solidFill>
-              </a:rPr>
-              <a:t>System Reliability: </a:t>
-            </a:r>
-            <a:r>
-              <a:rPr sz="1500">
-                <a:solidFill>
-                  <a:srgbClr val="333333"/>
-                </a:solidFill>
-              </a:rPr>
-              <a:t>All primary modules (Auth, Upload, QA, Summary, Quiz, Flashcards) passed automated verification.</a:t>
+              <a:t>Thank you for your time and attention. I am now open to questions from the honorable panel.</a:t>
             </a:r>
           </a:p>
         </p:txBody>

</xml_diff>

<commit_message>
Update Professional Project Defense Presentation (7 Slides structure)
</commit_message>
<xml_diff>
--- a/Professional_Project_Defense_Presentation_AuraQA.pptx
+++ b/Professional_Project_Defense_Presentation_AuraQA.pptx
@@ -12,7 +12,6 @@
     <p:sldId id="260" r:id="rId11"/>
     <p:sldId id="261" r:id="rId12"/>
     <p:sldId id="262" r:id="rId13"/>
-    <p:sldId id="263" r:id="rId14"/>
   </p:sldIdLst>
   <p:sldSz cx="12191695" cy="6858000" type="screen4x3"/>
   <p:notesSz cx="6858000" cy="9144000"/>
@@ -3118,14 +3117,14 @@
           <a:lstStyle/>
           <a:p>
             <a:pPr>
-              <a:defRPr sz="1900" b="1">
+              <a:defRPr sz="2200" b="1">
                 <a:solidFill>
                   <a:srgbClr val="1F4E78"/>
                 </a:solidFill>
               </a:defRPr>
             </a:pPr>
             <a:r>
-              <a:t>SLIDE 1: DESIGN AND IMPLEMENTATION OF AN INTELLIGENT DOCUMENT ANALYSIS AND LEARNING ASSISTANT SYSTEM (AuraQA)</a:t>
+              <a:t>DESIGN AND IMPLEMENTATION OF AN INTELLIGENT DOCUMENT ANALYSIS AND LEARNING ASSISTANT SYSTEM (AuraQA)</a:t>
             </a:r>
           </a:p>
           <a:p>
@@ -3328,7 +3327,7 @@
               </a:defRPr>
             </a:pPr>
             <a:r>
-              <a:t>SLIDE 2: SHORT ABSTRACT</a:t>
+              <a:t>SLIDE 2: INTRODUCTION</a:t>
             </a:r>
           </a:p>
           <a:p>
@@ -3340,7 +3339,7 @@
               </a:defRPr>
             </a:pPr>
             <a:r>
-              <a:t>Executive Summary of the Research Project</a:t>
+              <a:t>Abstract, Problem Statement, Aim &amp; Objectives</a:t>
             </a:r>
           </a:p>
         </p:txBody>
@@ -3378,7 +3377,7 @@
                   <a:srgbClr val="1F4E78"/>
                 </a:solidFill>
               </a:rPr>
-              <a:t>Problem Context: </a:t>
+              <a:t>Short Abstract: </a:t>
             </a:r>
             <a:r>
               <a:rPr sz="1500">
@@ -3386,7 +3385,7 @@
                   <a:srgbClr val="333333"/>
                 </a:solidFill>
               </a:rPr>
-              <a:t>Cloud-based LLMs present severe data privacy risks and high operational API costs when processing private academic documents.</a:t>
+              <a:t>AuraQA is a fully offline RAG system that eliminates cloud data privacy risks and API costs while optimizing CPU prefill latency.</a:t>
             </a:r>
           </a:p>
           <a:p>
@@ -3401,7 +3400,7 @@
                   <a:srgbClr val="1F4E78"/>
                 </a:solidFill>
               </a:rPr>
-              <a:t>Proposed Solution: </a:t>
+              <a:t>Problem Statement: </a:t>
             </a:r>
             <a:r>
               <a:rPr sz="1500">
@@ -3409,7 +3408,7 @@
                   <a:srgbClr val="333333"/>
                 </a:solidFill>
               </a:rPr>
-              <a:t>AuraQA introduces a fully offline Retrieval-Augmented Generation (RAG) system utilizing FAISS dense vector search and local LLMs.</a:t>
+              <a:t>Manual document reading is inefficient, keyword search lacks context, and cloud LLMs expose sensitive data to privacy risks.</a:t>
             </a:r>
           </a:p>
           <a:p>
@@ -3424,7 +3423,7 @@
                   <a:srgbClr val="1F4E78"/>
                 </a:solidFill>
               </a:rPr>
-              <a:t>Key Methodology: </a:t>
+              <a:t>Aim of the System: </a:t>
             </a:r>
             <a:r>
               <a:rPr sz="1500">
@@ -3432,7 +3431,7 @@
                   <a:srgbClr val="333333"/>
                 </a:solidFill>
               </a:rPr>
-              <a:t>Employs Prototyping SDLC, aligned 1000-char text chunking, and a deterministic rule-based query classifier (0.00s latency).</a:t>
+              <a:t>Develop a high-speed, secure, offline Intelligent Document Analysis and Learning Assistant System using local RAG.</a:t>
             </a:r>
           </a:p>
           <a:p>
@@ -3447,7 +3446,7 @@
                   <a:srgbClr val="1F4E78"/>
                 </a:solidFill>
               </a:rPr>
-              <a:t>Empirical Results: </a:t>
+              <a:t>Objectives: </a:t>
             </a:r>
             <a:r>
               <a:rPr sz="1500">
@@ -3455,30 +3454,7 @@
                   <a:srgbClr val="333333"/>
                 </a:solidFill>
               </a:rPr>
-              <a:t>Overall RAG CPU latency reduced by 48.57% (71.69s to 36.87s) with a 0.40 similarity threshold out-of-scope grounding shield.</a:t>
-            </a:r>
-          </a:p>
-          <a:p>
-            <a:pPr>
-              <a:spcAft>
-                <a:spcPts val="1000"/>
-              </a:spcAft>
-            </a:pPr>
-            <a:r>
-              <a:rPr b="1" sz="1500">
-                <a:solidFill>
-                  <a:srgbClr val="1F4E78"/>
-                </a:solidFill>
-              </a:rPr>
-              <a:t>Multilingual Support: </a:t>
-            </a:r>
-            <a:r>
-              <a:rPr sz="1500">
-                <a:solidFill>
-                  <a:srgbClr val="333333"/>
-                </a:solidFill>
-              </a:rPr>
-              <a:t>Native support for Hausa, Arabic, French, Spanish, German, and English query handling.</a:t>
+              <a:t>1. Support PDF, DOCX, TXT, CSV; 2. Local QA via Ollama (Qwen/Gemma); 3. Offline Summaries, Quizzes &amp; Flashcards; 4. Out-of-Scope Shield &amp; Hausa Support.</a:t>
             </a:r>
           </a:p>
         </p:txBody>
@@ -3531,7 +3507,7 @@
               </a:defRPr>
             </a:pPr>
             <a:r>
-              <a:t>SLIDE 3: AIM AND OBJECTIVES OF THE SYSTEM</a:t>
+              <a:t>SLIDE 3: LITERATURE REVIEW</a:t>
             </a:r>
           </a:p>
           <a:p>
@@ -3543,7 +3519,7 @@
               </a:defRPr>
             </a:pPr>
             <a:r>
-              <a:t>System Goals and Functional Capabilities</a:t>
+              <a:t>Theoretical Framework, RAG Paradigm &amp; Research Gap</a:t>
             </a:r>
           </a:p>
         </p:txBody>
@@ -3581,7 +3557,7 @@
                   <a:srgbClr val="1F4E78"/>
                 </a:solidFill>
               </a:rPr>
-              <a:t>Overall Aim: </a:t>
+              <a:t>Theoretical Framework: </a:t>
             </a:r>
             <a:r>
               <a:rPr sz="1500">
@@ -3589,7 +3565,7 @@
                   <a:srgbClr val="333333"/>
                 </a:solidFill>
               </a:rPr>
-              <a:t>Develop a high-speed, secure, offline Intelligent Document Analysis and Learning Assistant System using local RAG.</a:t>
+              <a:t>Retrieval-Augmented Generation (RAG) combines dense vector search with local generative models to eliminate AI hallucinations.</a:t>
             </a:r>
           </a:p>
           <a:p>
@@ -3604,7 +3580,7 @@
                   <a:srgbClr val="1F4E78"/>
                 </a:solidFill>
               </a:rPr>
-              <a:t>Objective 1 - Multi-format Parsing: </a:t>
+              <a:t>RAG Paradigm: </a:t>
             </a:r>
             <a:r>
               <a:rPr sz="1500">
@@ -3612,7 +3588,7 @@
                   <a:srgbClr val="333333"/>
                 </a:solidFill>
               </a:rPr>
-              <a:t>Support seamless text ingestion from PDF, DOCX, TXT, and CSV files with page/row tracking.</a:t>
+              <a:t>paraphrase-multilingual-MiniLM-L12-v2 generates 384-dim embeddings; FAISS FlatIP index enables instant cosine similarity retrieval.</a:t>
             </a:r>
           </a:p>
           <a:p>
@@ -3627,7 +3603,7 @@
                   <a:srgbClr val="1F4E78"/>
                 </a:solidFill>
               </a:rPr>
-              <a:t>Objective 2 - Local RAG QA: </a:t>
+              <a:t>Multilingual Foundation: </a:t>
             </a:r>
             <a:r>
               <a:rPr sz="1500">
@@ -3635,7 +3611,7 @@
                   <a:srgbClr val="333333"/>
                 </a:solidFill>
               </a:rPr>
-              <a:t>Provide context-grounded question answering using Ollama local models (Qwen 2.5 / Gemma 2).</a:t>
+              <a:t>Native cross-lingual vector alignment allows querying English documents in Hausa, Arabic, French, Spanish, and German.</a:t>
             </a:r>
           </a:p>
           <a:p>
@@ -3650,7 +3626,7 @@
                   <a:srgbClr val="1F4E78"/>
                 </a:solidFill>
               </a:rPr>
-              <a:t>Objective 3 - Study Mode Tools: </a:t>
+              <a:t>Research Gap: </a:t>
             </a:r>
             <a:r>
               <a:rPr sz="1500">
@@ -3658,30 +3634,7 @@
                   <a:srgbClr val="333333"/>
                 </a:solidFill>
               </a:rPr>
-              <a:t>Generate structured summaries, multiple-choice quizzes, and interactive study flashcards offline.</a:t>
-            </a:r>
-          </a:p>
-          <a:p>
-            <a:pPr>
-              <a:spcAft>
-                <a:spcPts val="1000"/>
-              </a:spcAft>
-            </a:pPr>
-            <a:r>
-              <a:rPr b="1" sz="1500">
-                <a:solidFill>
-                  <a:srgbClr val="1F4E78"/>
-                </a:solidFill>
-              </a:rPr>
-              <a:t>Objective 4 - Grounding Shield &amp; Multilingual: </a:t>
-            </a:r>
-            <a:r>
-              <a:rPr sz="1500">
-                <a:solidFill>
-                  <a:srgbClr val="333333"/>
-                </a:solidFill>
-              </a:rPr>
-              <a:t>Enforce a 0.40 similarity threshold to block out-of-scope hallucinations and support Hausa cross-lingual QA.</a:t>
+              <a:t>Bridging the gap between cloud-dependent LLMs and zero-cost, resource-constrained CPU offline hardware.</a:t>
             </a:r>
           </a:p>
         </p:txBody>
@@ -3734,7 +3687,7 @@
               </a:defRPr>
             </a:pPr>
             <a:r>
-              <a:t>SLIDE 4: SYSTEM DEVELOPMENT LIFE CYCLE (SDLC) &amp; METHODOLOGY</a:t>
+              <a:t>SLIDE 4: METHODOLOGIES</a:t>
             </a:r>
           </a:p>
           <a:p>
@@ -3746,7 +3699,7 @@
               </a:defRPr>
             </a:pPr>
             <a:r>
-              <a:t>Prototyping Methodology &amp; Phase Execution</a:t>
+              <a:t>SDLC Rationale, Ingestion Pipeline &amp; Tech Stack</a:t>
             </a:r>
           </a:p>
         </p:txBody>
@@ -3784,7 +3737,7 @@
                   <a:srgbClr val="1F4E78"/>
                 </a:solidFill>
               </a:rPr>
-              <a:t>What is the Methodology? </a:t>
+              <a:t>Why Prototyping SDLC? </a:t>
             </a:r>
             <a:r>
               <a:rPr sz="1500">
@@ -3792,7 +3745,7 @@
                   <a:srgbClr val="333333"/>
                 </a:solidFill>
               </a:rPr>
-              <a:t>Prototyping SDLC — an iterative 4-phase software engineering model chosen over rigid Waterfall for continuous experimental refinement.</a:t>
+              <a:t>1. Iterative Chunking (benchmarked 1000-char chunks + 150-char overlap); 2. UI Refinement (collapsible sidebar &amp; study tools); 3. Latency Optimization (0.00s router).</a:t>
             </a:r>
           </a:p>
           <a:p>
@@ -3807,7 +3760,7 @@
                   <a:srgbClr val="1F4E78"/>
                 </a:solidFill>
               </a:rPr>
-              <a:t>Phase 1 - Requirements &amp; Analysis: </a:t>
+              <a:t>Ingestion &amp; Extraction: </a:t>
             </a:r>
             <a:r>
               <a:rPr sz="1500">
@@ -3815,7 +3768,7 @@
                   <a:srgbClr val="333333"/>
                 </a:solidFill>
               </a:rPr>
-              <a:t>Defined offline data privacy requirements, multi-format ingestion needs (PDF, DOCX, CSV), and local CPU hardware latency constraints.</a:t>
+              <a:t>Multi-format text extraction (PDF, DOCX, TXT, CSV) mapped to exact page/row metadata for citation tracking.</a:t>
             </a:r>
           </a:p>
           <a:p>
@@ -3830,7 +3783,7 @@
                   <a:srgbClr val="1F4E78"/>
                 </a:solidFill>
               </a:rPr>
-              <a:t>Phase 2 - Quick Prototype Design: </a:t>
+              <a:t>Deterministic Classifier: </a:t>
             </a:r>
             <a:r>
               <a:rPr sz="1500">
@@ -3838,7 +3791,7 @@
                   <a:srgbClr val="333333"/>
                 </a:solidFill>
               </a:rPr>
-              <a:t>Built initial Next.js single-page UI, FastAPI backend services, SQLite database schemas, and FAISS vector indexing.</a:t>
+              <a:t>Rule-based query router bypasses slow LLM classification calls, executing intent routing in 0.00 seconds.</a:t>
             </a:r>
           </a:p>
           <a:p>
@@ -3853,7 +3806,7 @@
                   <a:srgbClr val="1F4E78"/>
                 </a:solidFill>
               </a:rPr>
-              <a:t>Phase 3 - Iterative Refinement &amp; Benchmarking: </a:t>
+              <a:t>Tools &amp; Tech Stack: </a:t>
             </a:r>
             <a:r>
               <a:rPr sz="1500">
@@ -3861,30 +3814,7 @@
                   <a:srgbClr val="333333"/>
                 </a:solidFill>
               </a:rPr>
-              <a:t>Iteratively benchmarked chunk sizes (finding 1000 chars + 150 overlap optimal) and created the 0.00s deterministic query classifier.</a:t>
-            </a:r>
-          </a:p>
-          <a:p>
-            <a:pPr>
-              <a:spcAft>
-                <a:spcPts val="1000"/>
-              </a:spcAft>
-            </a:pPr>
-            <a:r>
-              <a:rPr b="1" sz="1500">
-                <a:solidFill>
-                  <a:srgbClr val="1F4E78"/>
-                </a:solidFill>
-              </a:rPr>
-              <a:t>Phase 4 - Final System Evaluation &amp; Testing: </a:t>
-            </a:r>
-            <a:r>
-              <a:rPr sz="1500">
-                <a:solidFill>
-                  <a:srgbClr val="333333"/>
-                </a:solidFill>
-              </a:rPr>
-              <a:t>Validated out-of-scope grounding shield accuracy (threshold 0.40), Hausa query detection, and full offline execution.</a:t>
+              <a:t>Next.js 16 + Tailwind CSS (Frontend), FastAPI + SQLite (Backend), FAISS (Vector Store), Ollama Qwen 2.5/Gemma 2 (Local LLM).</a:t>
             </a:r>
           </a:p>
         </p:txBody>
@@ -3937,7 +3867,7 @@
               </a:defRPr>
             </a:pPr>
             <a:r>
-              <a:t>SLIDE 5: TESTING AND BENCHMARK RESULTS</a:t>
+              <a:t>SLIDE 5: SYSTEM DESIGN, IMPLEMENTATION &amp; RESULTS</a:t>
             </a:r>
           </a:p>
           <a:p>
@@ -3949,7 +3879,7 @@
               </a:defRPr>
             </a:pPr>
             <a:r>
-              <a:t>Empirical Performance Evaluation &amp; Latency Gains</a:t>
+              <a:t>Architecture, Key Features &amp; Benchmark Evaluation</a:t>
             </a:r>
           </a:p>
         </p:txBody>
@@ -3987,7 +3917,7 @@
                   <a:srgbClr val="1F4E78"/>
                 </a:solidFill>
               </a:rPr>
-              <a:t>RAG Execution Latency: </a:t>
+              <a:t>System Architecture: </a:t>
             </a:r>
             <a:r>
               <a:rPr sz="1500">
@@ -3995,7 +3925,7 @@
                   <a:srgbClr val="333333"/>
                 </a:solidFill>
               </a:rPr>
-              <a:t>Overall RAG execution time on CPU reduced by 48.57% (from 71.69s down to 36.87s).</a:t>
+              <a:t>User → Next.js SPA → FastAPI Server → Sentence Transformers → FAISS Index → Ollama LLM → Grounded Response.</a:t>
             </a:r>
           </a:p>
           <a:p>
@@ -4010,7 +3940,7 @@
                   <a:srgbClr val="1F4E78"/>
                 </a:solidFill>
               </a:rPr>
-              <a:t>Classifier Speedup: </a:t>
+              <a:t>Key Feature 1 - Grounded QA &amp; Chat: </a:t>
             </a:r>
             <a:r>
               <a:rPr sz="1500">
@@ -4018,7 +3948,7 @@
                   <a:srgbClr val="333333"/>
                 </a:solidFill>
               </a:rPr>
-              <a:t>Deterministic query router reduced intent classification latency from 12.4s down to 0.00s.</a:t>
+              <a:t>Interactive chat with Gemini-style sidebar, streaming responses, and out-of-scope grounding shield (0.40 threshold).</a:t>
             </a:r>
           </a:p>
           <a:p>
@@ -4033,7 +3963,7 @@
                   <a:srgbClr val="1F4E78"/>
                 </a:solidFill>
               </a:rPr>
-              <a:t>Grounding Shield Accuracy: </a:t>
+              <a:t>Key Features 2, 3 &amp; 4 - Study Mode &amp; Hausa: </a:t>
             </a:r>
             <a:r>
               <a:rPr sz="1500">
@@ -4041,7 +3971,7 @@
                   <a:srgbClr val="333333"/>
                 </a:solidFill>
               </a:rPr>
-              <a:t>0.40 cosine similarity threshold effectively blocked 100% of out-of-scope hallucinated queries.</a:t>
+              <a:t>Automated Summary extraction, Multiple-Choice Quiz generator, Study Flashcards, and Hausa (`ha`) cross-lingual QA.</a:t>
             </a:r>
           </a:p>
           <a:p>
@@ -4056,7 +3986,7 @@
                   <a:srgbClr val="1F4E78"/>
                 </a:solidFill>
               </a:rPr>
-              <a:t>System Reliability: </a:t>
+              <a:t>Benchmark Results: </a:t>
             </a:r>
             <a:r>
               <a:rPr sz="1500">
@@ -4064,7 +3994,7 @@
                   <a:srgbClr val="333333"/>
                 </a:solidFill>
               </a:rPr>
-              <a:t>All primary modules (Auth, Upload, QA, Summary, Quiz, Flashcards) passed automated verification.</a:t>
+              <a:t>Overall RAG CPU latency reduced by 48.57% (71.69s to 36.87s); router latency 0.00s; 100% out-of-scope hallucination block.</a:t>
             </a:r>
           </a:p>
         </p:txBody>
@@ -4117,7 +4047,7 @@
               </a:defRPr>
             </a:pPr>
             <a:r>
-              <a:t>SLIDE 6: CONCLUSION AND CONTRIBUTIONS</a:t>
+              <a:t>SLIDE 6: SUMMARY, CONCLUSION &amp; RECOMMENDATIONS</a:t>
             </a:r>
           </a:p>
           <a:p>
@@ -4129,7 +4059,7 @@
               </a:defRPr>
             </a:pPr>
             <a:r>
-              <a:t>Summary of Accomplishments and Significance</a:t>
+              <a:t>Achievements, Institutional Significance &amp; Future Work</a:t>
             </a:r>
           </a:p>
         </p:txBody>
@@ -4167,7 +4097,7 @@
                   <a:srgbClr val="1F4E78"/>
                 </a:solidFill>
               </a:rPr>
-              <a:t>Summary: </a:t>
+              <a:t>Summary of Achievements: </a:t>
             </a:r>
             <a:r>
               <a:rPr sz="1500">
@@ -4175,7 +4105,7 @@
                   <a:srgbClr val="333333"/>
                 </a:solidFill>
               </a:rPr>
-              <a:t>AuraQA successfully proves that high-performance, secure AI document intelligence is achievable locally on CPU hardware.</a:t>
+              <a:t>Built a fully functional, zero-cost, privacy-preserving offline learning assistant operating locally on standard laptop CPUs.</a:t>
             </a:r>
           </a:p>
           <a:p>
@@ -4190,7 +4120,7 @@
                   <a:srgbClr val="1F4E78"/>
                 </a:solidFill>
               </a:rPr>
-              <a:t>Data Sovereignty: </a:t>
+              <a:t>Conclusion: </a:t>
             </a:r>
             <a:r>
               <a:rPr sz="1500">
@@ -4198,7 +4128,7 @@
                   <a:srgbClr val="333333"/>
                 </a:solidFill>
               </a:rPr>
-              <a:t>Eliminates all third-party cloud data transmission, ensuring 100% user data privacy.</a:t>
+              <a:t>Proves that data sovereignty and high-performance AI document analysis are achievable without cloud API dependency.</a:t>
             </a:r>
           </a:p>
           <a:p>
@@ -4213,7 +4143,7 @@
                   <a:srgbClr val="1F4E78"/>
                 </a:solidFill>
               </a:rPr>
-              <a:t>Zero API Operational Cost: </a:t>
+              <a:t>Recommendations: </a:t>
             </a:r>
             <a:r>
               <a:rPr sz="1500">
@@ -4221,7 +4151,7 @@
                   <a:srgbClr val="333333"/>
                 </a:solidFill>
               </a:rPr>
-              <a:t>Provides educational institutions with unlimited AI assistance at zero API usage fees.</a:t>
+              <a:t>Deploy AuraQA across university libraries, research departments, and schools with limited internet connectivity.</a:t>
             </a:r>
           </a:p>
           <a:p>
@@ -4236,7 +4166,7 @@
                   <a:srgbClr val="1F4E78"/>
                 </a:solidFill>
               </a:rPr>
-              <a:t>Unified Learning Platform: </a:t>
+              <a:t>Future Extensions: </a:t>
             </a:r>
             <a:r>
               <a:rPr sz="1500">
@@ -4244,7 +4174,7 @@
                   <a:srgbClr val="333333"/>
                 </a:solidFill>
               </a:rPr>
-              <a:t>First system to integrate multi-lingual document QA, automated summarization, quizzes, and flashcards in one offline application.</a:t>
+              <a:t>Incorporate OCR for scanned documents, mobile runtime (ONNX), and local Whisper voice assistant interaction.</a:t>
             </a:r>
           </a:p>
         </p:txBody>
@@ -4297,7 +4227,7 @@
               </a:defRPr>
             </a:pPr>
             <a:r>
-              <a:t>SLIDE 7: KEY REFERENCES</a:t>
+              <a:t>SLIDE 7: REFERENCES &amp; DEFENSE CONCLUSION</a:t>
             </a:r>
           </a:p>
           <a:p>
@@ -4309,7 +4239,7 @@
               </a:defRPr>
             </a:pPr>
             <a:r>
-              <a:t>Short Academic Literature Citations</a:t>
+              <a:t>Short Academic Literature &amp; Panel Q&amp;A</a:t>
             </a:r>
           </a:p>
         </p:txBody>
@@ -4355,7 +4285,7 @@
                   <a:srgbClr val="333333"/>
                 </a:solidFill>
               </a:rPr>
-              <a:t>Retrieval-Augmented Generation for Knowledge-Intensive NLP Tasks. Advances in Neural Information Processing Systems (NeurIPS).</a:t>
+              <a:t>Retrieval-Augmented Generation for Knowledge-Intensive NLP Tasks. NeurIPS.</a:t>
             </a:r>
           </a:p>
           <a:p>
@@ -4378,7 +4308,7 @@
                   <a:srgbClr val="333333"/>
                 </a:solidFill>
               </a:rPr>
-              <a:t>Billion-scale similarity search with GPUs. IEEE Transactions on Big Data, 7(3), 535-547 (FAISS Framework).</a:t>
+              <a:t>Billion-scale similarity search with GPUs. IEEE Transactions on Big Data (FAISS Framework).</a:t>
             </a:r>
           </a:p>
           <a:p>
@@ -4401,7 +4331,7 @@
                   <a:srgbClr val="333333"/>
                 </a:solidFill>
               </a:rPr>
-              <a:t>Sentence-BERT: Sentence Embeddings using Siamese BERT-Networks. Proceedings of EMNLP.</a:t>
+              <a:t>Sentence-BERT: Sentence Embeddings using Siamese BERT-Networks. EMNLP.</a:t>
             </a:r>
           </a:p>
           <a:p>
@@ -4424,97 +4354,9 @@
                   <a:srgbClr val="333333"/>
                 </a:solidFill>
               </a:rPr>
-              <a:t>Attention Is All You Need. Advances in Neural Information Processing Systems (Transformer Architecture).</a:t>
-            </a:r>
-          </a:p>
-        </p:txBody>
-      </p:sp>
-    </p:spTree>
-  </p:cSld>
-  <p:clrMapOvr>
-    <a:masterClrMapping/>
-  </p:clrMapOvr>
-</p:sld>
-</file>
-
-<file path=ppt/slides/slide8.xml><?xml version="1.0" encoding="utf-8"?>
-<p:sld xmlns:a="http://schemas.openxmlformats.org/drawingml/2006/main" xmlns:p="http://schemas.openxmlformats.org/presentationml/2006/main" xmlns:r="http://schemas.openxmlformats.org/officeDocument/2006/relationships">
-  <p:cSld>
-    <p:spTree>
-      <p:nvGrpSpPr>
-        <p:cNvPr id="1" name=""/>
-        <p:cNvGrpSpPr/>
-        <p:nvPr/>
-      </p:nvGrpSpPr>
-      <p:grpSpPr/>
-      <p:sp>
-        <p:nvSpPr>
-          <p:cNvPr id="2" name="TextBox 1"/>
-          <p:cNvSpPr txBox="1"/>
-          <p:nvPr/>
-        </p:nvSpPr>
-        <p:spPr>
-          <a:xfrm>
-            <a:off x="731520" y="457200"/>
-            <a:ext cx="10698480" cy="1097280"/>
-          </a:xfrm>
-          <a:prstGeom prst="rect">
-            <a:avLst/>
-          </a:prstGeom>
-          <a:noFill/>
-        </p:spPr>
-        <p:txBody>
-          <a:bodyPr wrap="square">
-            <a:spAutoFit/>
-          </a:bodyPr>
-          <a:lstStyle/>
-          <a:p>
-            <a:pPr>
-              <a:defRPr sz="2200" b="1">
-                <a:solidFill>
-                  <a:srgbClr val="1F4E78"/>
-                </a:solidFill>
-              </a:defRPr>
-            </a:pPr>
-            <a:r>
-              <a:t>SLIDE 8: RECOMMENDATIONS &amp; FUTURE WORK</a:t>
-            </a:r>
-          </a:p>
-          <a:p>
-            <a:pPr>
-              <a:defRPr sz="1300" i="1">
-                <a:solidFill>
-                  <a:srgbClr val="595959"/>
-                </a:solidFill>
-              </a:defRPr>
-            </a:pPr>
-            <a:r>
-              <a:t>Future Extensions &amp; Defense Panel Q&amp;A</a:t>
-            </a:r>
-          </a:p>
-        </p:txBody>
-      </p:sp>
-      <p:sp>
-        <p:nvSpPr>
-          <p:cNvPr id="3" name="TextBox 2"/>
-          <p:cNvSpPr txBox="1"/>
-          <p:nvPr/>
-        </p:nvSpPr>
-        <p:spPr>
-          <a:xfrm>
-            <a:off x="731520" y="1645920"/>
-            <a:ext cx="10698480" cy="4572000"/>
-          </a:xfrm>
-          <a:prstGeom prst="rect">
-            <a:avLst/>
-          </a:prstGeom>
-          <a:noFill/>
-        </p:spPr>
-        <p:txBody>
-          <a:bodyPr wrap="square">
-            <a:spAutoFit/>
-          </a:bodyPr>
-          <a:lstStyle/>
+              <a:t>Attention Is All You Need. NeurIPS (Transformer Architecture).</a:t>
+            </a:r>
+          </a:p>
           <a:p>
             <a:pPr>
               <a:spcAft>
@@ -4527,7 +4369,7 @@
                   <a:srgbClr val="1F4E78"/>
                 </a:solidFill>
               </a:rPr>
-              <a:t>Recommendation 1 (OCR Integration): </a:t>
+              <a:t>Acknowledgement &amp; Q&amp;A: </a:t>
             </a:r>
             <a:r>
               <a:rPr sz="1500">
@@ -4535,76 +4377,7 @@
                   <a:srgbClr val="333333"/>
                 </a:solidFill>
               </a:rPr>
-              <a:t>Incorporate Optical Character Recognition (Tesseract/PaddleOCR) for scanned paper documents.</a:t>
-            </a:r>
-          </a:p>
-          <a:p>
-            <a:pPr>
-              <a:spcAft>
-                <a:spcPts val="1000"/>
-              </a:spcAft>
-            </a:pPr>
-            <a:r>
-              <a:rPr b="1" sz="1500">
-                <a:solidFill>
-                  <a:srgbClr val="1F4E78"/>
-                </a:solidFill>
-              </a:rPr>
-              <a:t>Recommendation 2 (Mobile App): </a:t>
-            </a:r>
-            <a:r>
-              <a:rPr sz="1500">
-                <a:solidFill>
-                  <a:srgbClr val="333333"/>
-                </a:solidFill>
-              </a:rPr>
-              <a:t>Develop a lightweight cross-platform mobile application powered by ONNX runtime.</a:t>
-            </a:r>
-          </a:p>
-          <a:p>
-            <a:pPr>
-              <a:spcAft>
-                <a:spcPts val="1000"/>
-              </a:spcAft>
-            </a:pPr>
-            <a:r>
-              <a:rPr b="1" sz="1500">
-                <a:solidFill>
-                  <a:srgbClr val="1F4E78"/>
-                </a:solidFill>
-              </a:rPr>
-              <a:t>Recommendation 3 (Voice Assistant): </a:t>
-            </a:r>
-            <a:r>
-              <a:rPr sz="1500">
-                <a:solidFill>
-                  <a:srgbClr val="333333"/>
-                </a:solidFill>
-              </a:rPr>
-              <a:t>Integrate local Whisper Speech-to-Text for hands-free voice interaction.</a:t>
-            </a:r>
-          </a:p>
-          <a:p>
-            <a:pPr>
-              <a:spcAft>
-                <a:spcPts val="1000"/>
-              </a:spcAft>
-            </a:pPr>
-            <a:r>
-              <a:rPr b="1" sz="1500">
-                <a:solidFill>
-                  <a:srgbClr val="1F4E78"/>
-                </a:solidFill>
-              </a:rPr>
-              <a:t>Acknowledgement &amp; Q&amp;A: </a:t>
-            </a:r>
-            <a:r>
-              <a:rPr sz="1500">
-                <a:solidFill>
-                  <a:srgbClr val="333333"/>
-                </a:solidFill>
-              </a:rPr>
-              <a:t>Thank you for your time and attention. I am now open to questions from the honorable panel.</a:t>
+              <a:t>Heartfelt thanks to FUK, Supervisor Dr. David Oyewola, HOD Dr. (Mrs.) Asabe. Open for panel questions.</a:t>
             </a:r>
           </a:p>
         </p:txBody>

</xml_diff>